<commit_message>
Bump remaining small eyebrows, attributions, pricing labels and CTA text in deck
</commit_message>
<xml_diff>
--- a/wla-summer-challenge-launch.pptx
+++ b/wla-summer-challenge-launch.pptx
@@ -3559,7 +3559,7 @@
               </a:lnSpc>
             </a:pPr>
             <a:r>
-              <a:rPr sz="1200" b="1" i="0" spc="260">
+              <a:rPr sz="1800" b="1" i="0" spc="240">
                 <a:solidFill>
                   <a:srgbClr val="D97757"/>
                 </a:solidFill>
@@ -3671,7 +3671,7 @@
               </a:lnSpc>
             </a:pPr>
             <a:r>
-              <a:rPr sz="1300" b="1" i="0" spc="200">
+              <a:rPr sz="1600" b="1" i="0" spc="200">
                 <a:solidFill>
                   <a:srgbClr val="5A6478"/>
                 </a:solidFill>
@@ -3850,7 +3850,7 @@
               </a:lnSpc>
             </a:pPr>
             <a:r>
-              <a:rPr sz="1200" b="1" i="0" spc="260">
+              <a:rPr sz="1800" b="1" i="0" spc="240">
                 <a:solidFill>
                   <a:srgbClr val="D97757"/>
                 </a:solidFill>
@@ -22285,7 +22285,7 @@
               </a:lnSpc>
             </a:pPr>
             <a:r>
-              <a:rPr sz="1200" b="1" i="0" spc="240">
+              <a:rPr sz="1700" b="1" i="0" spc="220">
                 <a:solidFill>
                   <a:srgbClr val="D97757"/>
                 </a:solidFill>
@@ -22304,8 +22304,8 @@
         </p:nvSpPr>
         <p:spPr>
           <a:xfrm>
-            <a:off x="822960" y="5486400"/>
-            <a:ext cx="164592" cy="164592"/>
+            <a:off x="822960" y="5513832"/>
+            <a:ext cx="219456" cy="219456"/>
           </a:xfrm>
           <a:prstGeom prst="ellipse">
             <a:avLst/>
@@ -22357,27 +22357,27 @@
         </p:nvSpPr>
         <p:spPr>
           <a:xfrm>
-            <a:off x="1115568" y="5440680"/>
-            <a:ext cx="5303520" cy="365760"/>
-          </a:xfrm>
-          <a:prstGeom prst="rect">
-            <a:avLst/>
-          </a:prstGeom>
-          <a:noFill/>
-        </p:spPr>
-        <p:txBody>
-          <a:bodyPr wrap="square" lIns="0" rIns="0" tIns="0" bIns="0" anchor="t">
-            <a:spAutoFit/>
-          </a:bodyPr>
-          <a:lstStyle/>
-          <a:p>
-            <a:pPr algn="l">
-              <a:lnSpc>
-                <a:spcPct val="120000"/>
-              </a:lnSpc>
-            </a:pPr>
-            <a:r>
-              <a:rPr sz="1400" b="1" i="0">
+            <a:off x="1188720" y="5440680"/>
+            <a:ext cx="5303520" cy="457200"/>
+          </a:xfrm>
+          <a:prstGeom prst="rect">
+            <a:avLst/>
+          </a:prstGeom>
+          <a:noFill/>
+        </p:spPr>
+        <p:txBody>
+          <a:bodyPr wrap="square" lIns="0" rIns="0" tIns="0" bIns="0" anchor="t">
+            <a:spAutoFit/>
+          </a:bodyPr>
+          <a:lstStyle/>
+          <a:p>
+            <a:pPr algn="l">
+              <a:lnSpc>
+                <a:spcPct val="120000"/>
+              </a:lnSpc>
+            </a:pPr>
+            <a:r>
+              <a:rPr sz="1700" b="1" i="0">
                 <a:solidFill>
                   <a:srgbClr val="0E2746"/>
                 </a:solidFill>
@@ -22396,8 +22396,8 @@
         </p:nvSpPr>
         <p:spPr>
           <a:xfrm>
-            <a:off x="6400800" y="5486400"/>
-            <a:ext cx="164592" cy="164592"/>
+            <a:off x="6400800" y="5513832"/>
+            <a:ext cx="219456" cy="219456"/>
           </a:xfrm>
           <a:prstGeom prst="ellipse">
             <a:avLst/>
@@ -22449,27 +22449,27 @@
         </p:nvSpPr>
         <p:spPr>
           <a:xfrm>
-            <a:off x="6693408" y="5440680"/>
-            <a:ext cx="5303520" cy="365760"/>
-          </a:xfrm>
-          <a:prstGeom prst="rect">
-            <a:avLst/>
-          </a:prstGeom>
-          <a:noFill/>
-        </p:spPr>
-        <p:txBody>
-          <a:bodyPr wrap="square" lIns="0" rIns="0" tIns="0" bIns="0" anchor="t">
-            <a:spAutoFit/>
-          </a:bodyPr>
-          <a:lstStyle/>
-          <a:p>
-            <a:pPr algn="l">
-              <a:lnSpc>
-                <a:spcPct val="120000"/>
-              </a:lnSpc>
-            </a:pPr>
-            <a:r>
-              <a:rPr sz="1400" b="1" i="0">
+            <a:off x="6766560" y="5440680"/>
+            <a:ext cx="5303520" cy="457200"/>
+          </a:xfrm>
+          <a:prstGeom prst="rect">
+            <a:avLst/>
+          </a:prstGeom>
+          <a:noFill/>
+        </p:spPr>
+        <p:txBody>
+          <a:bodyPr wrap="square" lIns="0" rIns="0" tIns="0" bIns="0" anchor="t">
+            <a:spAutoFit/>
+          </a:bodyPr>
+          <a:lstStyle/>
+          <a:p>
+            <a:pPr algn="l">
+              <a:lnSpc>
+                <a:spcPct val="120000"/>
+              </a:lnSpc>
+            </a:pPr>
+            <a:r>
+              <a:rPr sz="1700" b="1" i="0">
                 <a:solidFill>
                   <a:srgbClr val="0E2746"/>
                 </a:solidFill>
@@ -22488,8 +22488,8 @@
         </p:nvSpPr>
         <p:spPr>
           <a:xfrm>
-            <a:off x="822960" y="5897880"/>
-            <a:ext cx="164592" cy="164592"/>
+            <a:off x="822960" y="5925312"/>
+            <a:ext cx="219456" cy="219456"/>
           </a:xfrm>
           <a:prstGeom prst="ellipse">
             <a:avLst/>
@@ -22541,27 +22541,27 @@
         </p:nvSpPr>
         <p:spPr>
           <a:xfrm>
-            <a:off x="1115568" y="5852160"/>
-            <a:ext cx="5303520" cy="365760"/>
-          </a:xfrm>
-          <a:prstGeom prst="rect">
-            <a:avLst/>
-          </a:prstGeom>
-          <a:noFill/>
-        </p:spPr>
-        <p:txBody>
-          <a:bodyPr wrap="square" lIns="0" rIns="0" tIns="0" bIns="0" anchor="t">
-            <a:spAutoFit/>
-          </a:bodyPr>
-          <a:lstStyle/>
-          <a:p>
-            <a:pPr algn="l">
-              <a:lnSpc>
-                <a:spcPct val="120000"/>
-              </a:lnSpc>
-            </a:pPr>
-            <a:r>
-              <a:rPr sz="1400" b="1" i="0">
+            <a:off x="1188720" y="5852160"/>
+            <a:ext cx="5303520" cy="457200"/>
+          </a:xfrm>
+          <a:prstGeom prst="rect">
+            <a:avLst/>
+          </a:prstGeom>
+          <a:noFill/>
+        </p:spPr>
+        <p:txBody>
+          <a:bodyPr wrap="square" lIns="0" rIns="0" tIns="0" bIns="0" anchor="t">
+            <a:spAutoFit/>
+          </a:bodyPr>
+          <a:lstStyle/>
+          <a:p>
+            <a:pPr algn="l">
+              <a:lnSpc>
+                <a:spcPct val="120000"/>
+              </a:lnSpc>
+            </a:pPr>
+            <a:r>
+              <a:rPr sz="1700" b="1" i="0">
                 <a:solidFill>
                   <a:srgbClr val="0E2746"/>
                 </a:solidFill>
@@ -22580,8 +22580,8 @@
         </p:nvSpPr>
         <p:spPr>
           <a:xfrm>
-            <a:off x="6400800" y="5897880"/>
-            <a:ext cx="164592" cy="164592"/>
+            <a:off x="6400800" y="5925312"/>
+            <a:ext cx="219456" cy="219456"/>
           </a:xfrm>
           <a:prstGeom prst="ellipse">
             <a:avLst/>
@@ -22633,27 +22633,27 @@
         </p:nvSpPr>
         <p:spPr>
           <a:xfrm>
-            <a:off x="6693408" y="5852160"/>
-            <a:ext cx="5303520" cy="365760"/>
-          </a:xfrm>
-          <a:prstGeom prst="rect">
-            <a:avLst/>
-          </a:prstGeom>
-          <a:noFill/>
-        </p:spPr>
-        <p:txBody>
-          <a:bodyPr wrap="square" lIns="0" rIns="0" tIns="0" bIns="0" anchor="t">
-            <a:spAutoFit/>
-          </a:bodyPr>
-          <a:lstStyle/>
-          <a:p>
-            <a:pPr algn="l">
-              <a:lnSpc>
-                <a:spcPct val="120000"/>
-              </a:lnSpc>
-            </a:pPr>
-            <a:r>
-              <a:rPr sz="1400" b="1" i="0">
+            <a:off x="6766560" y="5852160"/>
+            <a:ext cx="5303520" cy="457200"/>
+          </a:xfrm>
+          <a:prstGeom prst="rect">
+            <a:avLst/>
+          </a:prstGeom>
+          <a:noFill/>
+        </p:spPr>
+        <p:txBody>
+          <a:bodyPr wrap="square" lIns="0" rIns="0" tIns="0" bIns="0" anchor="t">
+            <a:spAutoFit/>
+          </a:bodyPr>
+          <a:lstStyle/>
+          <a:p>
+            <a:pPr algn="l">
+              <a:lnSpc>
+                <a:spcPct val="120000"/>
+              </a:lnSpc>
+            </a:pPr>
+            <a:r>
+              <a:rPr sz="1700" b="1" i="0">
                 <a:solidFill>
                   <a:srgbClr val="0E2746"/>
                 </a:solidFill>
@@ -22672,8 +22672,8 @@
         </p:nvSpPr>
         <p:spPr>
           <a:xfrm>
-            <a:off x="822960" y="6309360"/>
-            <a:ext cx="164592" cy="164592"/>
+            <a:off x="822960" y="6336792"/>
+            <a:ext cx="219456" cy="219456"/>
           </a:xfrm>
           <a:prstGeom prst="ellipse">
             <a:avLst/>
@@ -22725,27 +22725,27 @@
         </p:nvSpPr>
         <p:spPr>
           <a:xfrm>
-            <a:off x="1115568" y="6263640"/>
-            <a:ext cx="5303520" cy="365760"/>
-          </a:xfrm>
-          <a:prstGeom prst="rect">
-            <a:avLst/>
-          </a:prstGeom>
-          <a:noFill/>
-        </p:spPr>
-        <p:txBody>
-          <a:bodyPr wrap="square" lIns="0" rIns="0" tIns="0" bIns="0" anchor="t">
-            <a:spAutoFit/>
-          </a:bodyPr>
-          <a:lstStyle/>
-          <a:p>
-            <a:pPr algn="l">
-              <a:lnSpc>
-                <a:spcPct val="120000"/>
-              </a:lnSpc>
-            </a:pPr>
-            <a:r>
-              <a:rPr sz="1400" b="1" i="0">
+            <a:off x="1188720" y="6263640"/>
+            <a:ext cx="5303520" cy="457200"/>
+          </a:xfrm>
+          <a:prstGeom prst="rect">
+            <a:avLst/>
+          </a:prstGeom>
+          <a:noFill/>
+        </p:spPr>
+        <p:txBody>
+          <a:bodyPr wrap="square" lIns="0" rIns="0" tIns="0" bIns="0" anchor="t">
+            <a:spAutoFit/>
+          </a:bodyPr>
+          <a:lstStyle/>
+          <a:p>
+            <a:pPr algn="l">
+              <a:lnSpc>
+                <a:spcPct val="120000"/>
+              </a:lnSpc>
+            </a:pPr>
+            <a:r>
+              <a:rPr sz="1700" b="1" i="0">
                 <a:solidFill>
                   <a:srgbClr val="0E2746"/>
                 </a:solidFill>
@@ -23025,7 +23025,7 @@
               </a:lnSpc>
             </a:pPr>
             <a:r>
-              <a:rPr sz="1400" b="0" i="0">
+              <a:rPr sz="1600" b="0" i="0">
                 <a:solidFill>
                   <a:srgbClr val="333333"/>
                 </a:solidFill>
@@ -23156,7 +23156,7 @@
               </a:lnSpc>
             </a:pPr>
             <a:r>
-              <a:rPr sz="1400" b="0" i="0">
+              <a:rPr sz="1600" b="0" i="0">
                 <a:solidFill>
                   <a:srgbClr val="333333"/>
                 </a:solidFill>
@@ -23287,7 +23287,7 @@
               </a:lnSpc>
             </a:pPr>
             <a:r>
-              <a:rPr sz="1400" b="0" i="0">
+              <a:rPr sz="1600" b="0" i="0">
                 <a:solidFill>
                   <a:srgbClr val="333333"/>
                 </a:solidFill>
@@ -23418,7 +23418,7 @@
               </a:lnSpc>
             </a:pPr>
             <a:r>
-              <a:rPr sz="1400" b="0" i="0">
+              <a:rPr sz="1600" b="0" i="0">
                 <a:solidFill>
                   <a:srgbClr val="333333"/>
                 </a:solidFill>
@@ -23549,7 +23549,7 @@
               </a:lnSpc>
             </a:pPr>
             <a:r>
-              <a:rPr sz="1400" b="0" i="0">
+              <a:rPr sz="1600" b="0" i="0">
                 <a:solidFill>
                   <a:srgbClr val="333333"/>
                 </a:solidFill>
@@ -23831,7 +23831,7 @@
               </a:lnSpc>
             </a:pPr>
             <a:r>
-              <a:rPr sz="1400" b="1" i="0" spc="280">
+              <a:rPr sz="1800" b="1" i="0" spc="240">
                 <a:solidFill>
                   <a:srgbClr val="5A6478"/>
                 </a:solidFill>
@@ -23918,7 +23918,7 @@
               </a:lnSpc>
             </a:pPr>
             <a:r>
-              <a:rPr sz="1400" b="1" i="0" spc="220">
+              <a:rPr sz="1700" b="1" i="0" spc="200">
                 <a:solidFill>
                   <a:srgbClr val="5A6478"/>
                 </a:solidFill>
@@ -24175,7 +24175,7 @@
               </a:lnSpc>
             </a:pPr>
             <a:r>
-              <a:rPr sz="1200" b="1" i="0" spc="280">
+              <a:rPr sz="1800" b="1" i="0" spc="240">
                 <a:solidFill>
                   <a:srgbClr val="D97757"/>
                 </a:solidFill>
@@ -26555,7 +26555,7 @@
               </a:lnSpc>
             </a:pPr>
             <a:r>
-              <a:rPr sz="1400" b="1" i="0" spc="260">
+              <a:rPr sz="1800" b="1" i="0" spc="240">
                 <a:solidFill>
                   <a:srgbClr val="FFFFFF"/>
                 </a:solidFill>
@@ -26594,7 +26594,7 @@
               </a:lnSpc>
             </a:pPr>
             <a:r>
-              <a:rPr sz="1200" b="0" i="0" spc="150">
+              <a:rPr sz="1600" b="0" i="0" spc="150">
                 <a:solidFill>
                   <a:srgbClr val="F4EBDC"/>
                 </a:solidFill>
@@ -27067,7 +27067,7 @@
               </a:lnSpc>
             </a:pPr>
             <a:r>
-              <a:rPr sz="1200" b="1" i="0" spc="240">
+              <a:rPr sz="1800" b="1" i="0" spc="220">
                 <a:solidFill>
                   <a:srgbClr val="D97757"/>
                 </a:solidFill>

</xml_diff>

<commit_message>
Bump feature/phase2 counter eyebrows in deck (16pt -> 20pt)
</commit_message>
<xml_diff>
--- a/wla-summer-challenge-launch.pptx
+++ b/wla-summer-challenge-launch.pptx
@@ -9903,7 +9903,7 @@
               </a:lnSpc>
             </a:pPr>
             <a:r>
-              <a:rPr sz="1600" b="1" i="0" spc="220">
+              <a:rPr sz="2000" b="1" i="0" spc="200">
                 <a:solidFill>
                   <a:srgbClr val="D97757"/>
                 </a:solidFill>
@@ -10653,7 +10653,7 @@
               </a:lnSpc>
             </a:pPr>
             <a:r>
-              <a:rPr sz="1600" b="1" i="0" spc="220">
+              <a:rPr sz="2000" b="1" i="0" spc="200">
                 <a:solidFill>
                   <a:srgbClr val="D97757"/>
                 </a:solidFill>
@@ -11403,7 +11403,7 @@
               </a:lnSpc>
             </a:pPr>
             <a:r>
-              <a:rPr sz="1600" b="1" i="0" spc="220">
+              <a:rPr sz="2000" b="1" i="0" spc="200">
                 <a:solidFill>
                   <a:srgbClr val="D97757"/>
                 </a:solidFill>
@@ -12070,7 +12070,7 @@
               </a:lnSpc>
             </a:pPr>
             <a:r>
-              <a:rPr sz="1600" b="1" i="0" spc="220">
+              <a:rPr sz="2000" b="1" i="0" spc="200">
                 <a:solidFill>
                   <a:srgbClr val="D97757"/>
                 </a:solidFill>
@@ -12654,7 +12654,7 @@
               </a:lnSpc>
             </a:pPr>
             <a:r>
-              <a:rPr sz="1600" b="1" i="0" spc="220">
+              <a:rPr sz="2000" b="1" i="0" spc="200">
                 <a:solidFill>
                   <a:srgbClr val="D97757"/>
                 </a:solidFill>
@@ -13404,7 +13404,7 @@
               </a:lnSpc>
             </a:pPr>
             <a:r>
-              <a:rPr sz="1600" b="1" i="0" spc="220">
+              <a:rPr sz="2000" b="1" i="0" spc="200">
                 <a:solidFill>
                   <a:srgbClr val="D97757"/>
                 </a:solidFill>
@@ -14888,7 +14888,7 @@
               </a:lnSpc>
             </a:pPr>
             <a:r>
-              <a:rPr sz="1600" b="1" i="0" spc="220">
+              <a:rPr sz="2000" b="1" i="0" spc="200">
                 <a:solidFill>
                   <a:srgbClr val="D97757"/>
                 </a:solidFill>
@@ -15887,7 +15887,7 @@
               </a:lnSpc>
             </a:pPr>
             <a:r>
-              <a:rPr sz="1600" b="1" i="0" spc="220">
+              <a:rPr sz="2000" b="1" i="0" spc="200">
                 <a:solidFill>
                   <a:srgbClr val="D97757"/>
                 </a:solidFill>
@@ -16554,7 +16554,7 @@
               </a:lnSpc>
             </a:pPr>
             <a:r>
-              <a:rPr sz="1600" b="1" i="0" spc="220">
+              <a:rPr sz="2000" b="1" i="0" spc="200">
                 <a:solidFill>
                   <a:srgbClr val="D97757"/>
                 </a:solidFill>
@@ -17304,7 +17304,7 @@
               </a:lnSpc>
             </a:pPr>
             <a:r>
-              <a:rPr sz="1600" b="1" i="0" spc="220">
+              <a:rPr sz="2000" b="1" i="0" spc="200">
                 <a:solidFill>
                   <a:srgbClr val="D97757"/>
                 </a:solidFill>
@@ -18530,7 +18530,7 @@
               </a:lnSpc>
             </a:pPr>
             <a:r>
-              <a:rPr sz="1600" b="1" i="0" spc="220">
+              <a:rPr sz="2000" b="1" i="0" spc="200">
                 <a:solidFill>
                   <a:srgbClr val="D97757"/>
                 </a:solidFill>
@@ -19158,7 +19158,7 @@
               </a:lnSpc>
             </a:pPr>
             <a:r>
-              <a:rPr sz="1600" b="1" i="0" spc="220">
+              <a:rPr sz="2000" b="1" i="0" spc="200">
                 <a:solidFill>
                   <a:srgbClr val="D97757"/>
                 </a:solidFill>
@@ -19786,7 +19786,7 @@
               </a:lnSpc>
             </a:pPr>
             <a:r>
-              <a:rPr sz="1600" b="1" i="0" spc="220">
+              <a:rPr sz="2000" b="1" i="0" spc="200">
                 <a:solidFill>
                   <a:srgbClr val="D97757"/>
                 </a:solidFill>
@@ -20331,7 +20331,7 @@
               </a:lnSpc>
             </a:pPr>
             <a:r>
-              <a:rPr sz="1600" b="1" i="0" spc="220">
+              <a:rPr sz="2000" b="1" i="0" spc="200">
                 <a:solidFill>
                   <a:srgbClr val="D97757"/>
                 </a:solidFill>

</xml_diff>

<commit_message>
Tighten vertical spacing on callout slides (5, 10, 20, 41, 46, 49, 50)
</commit_message>
<xml_diff>
--- a/wla-summer-challenge-launch.pptx
+++ b/wla-summer-challenge-launch.pptx
@@ -3539,21 +3539,21 @@
         </p:nvSpPr>
         <p:spPr>
           <a:xfrm>
-            <a:off x="822960" y="731520"/>
-            <a:ext cx="10515600" cy="365760"/>
-          </a:xfrm>
-          <a:prstGeom prst="rect">
-            <a:avLst/>
-          </a:prstGeom>
-          <a:noFill/>
-        </p:spPr>
-        <p:txBody>
-          <a:bodyPr wrap="square" lIns="0" rIns="0" tIns="0" bIns="0" anchor="t">
-            <a:spAutoFit/>
-          </a:bodyPr>
-          <a:lstStyle/>
-          <a:p>
-            <a:pPr algn="l">
+            <a:off x="822960" y="777240"/>
+            <a:ext cx="10515600" cy="457200"/>
+          </a:xfrm>
+          <a:prstGeom prst="rect">
+            <a:avLst/>
+          </a:prstGeom>
+          <a:noFill/>
+        </p:spPr>
+        <p:txBody>
+          <a:bodyPr wrap="square" lIns="0" rIns="0" tIns="0" bIns="0" anchor="t">
+            <a:spAutoFit/>
+          </a:bodyPr>
+          <a:lstStyle/>
+          <a:p>
+            <a:pPr algn="ctr">
               <a:lnSpc>
                 <a:spcPct val="120000"/>
               </a:lnSpc>
@@ -3579,7 +3579,7 @@
         <p:spPr>
           <a:xfrm>
             <a:off x="1097280" y="1920240"/>
-            <a:ext cx="9966960" cy="3657600"/>
+            <a:ext cx="9966960" cy="4572000"/>
           </a:xfrm>
           <a:prstGeom prst="rect">
             <a:avLst/>
@@ -3594,11 +3594,11 @@
           <a:p>
             <a:pPr algn="ctr">
               <a:lnSpc>
-                <a:spcPct val="115000"/>
-              </a:lnSpc>
-            </a:pPr>
-            <a:r>
-              <a:rPr sz="4800" b="0" i="1">
+                <a:spcPct val="118000"/>
+              </a:lnSpc>
+            </a:pPr>
+            <a:r>
+              <a:rPr sz="4400" b="0" i="1">
                 <a:solidFill>
                   <a:srgbClr val="0E2746"/>
                 </a:solidFill>
@@ -3610,11 +3610,14 @@
           <a:p>
             <a:pPr algn="ctr">
               <a:lnSpc>
-                <a:spcPct val="115000"/>
-              </a:lnSpc>
-            </a:pPr>
-            <a:r>
-              <a:rPr sz="4800" b="0" i="1">
+                <a:spcPct val="118000"/>
+              </a:lnSpc>
+              <a:spcAft>
+                <a:spcPts val="2800"/>
+              </a:spcAft>
+            </a:pPr>
+            <a:r>
+              <a:rPr sz="4400" b="0" i="1">
                 <a:solidFill>
                   <a:srgbClr val="0E2746"/>
                 </a:solidFill>
@@ -3623,7 +3626,7 @@
               <a:t>usually </a:t>
             </a:r>
             <a:r>
-              <a:rPr sz="4800" b="1" i="1">
+              <a:rPr sz="4400" b="1" i="1">
                 <a:solidFill>
                   <a:srgbClr val="D97757"/>
                 </a:solidFill>
@@ -3632,7 +3635,7 @@
               <a:t>continue the lifestyle</a:t>
             </a:r>
             <a:r>
-              <a:rPr sz="4800" b="0" i="1">
+              <a:rPr sz="4400" b="0" i="1">
                 <a:solidFill>
                   <a:srgbClr val="0E2746"/>
                 </a:solidFill>
@@ -3641,50 +3644,27 @@
               <a:t>.”</a:t>
             </a:r>
           </a:p>
+          <a:p>
+            <a:pPr algn="ctr">
+              <a:lnSpc>
+                <a:spcPct val="130000"/>
+              </a:lnSpc>
+            </a:pPr>
+            <a:r>
+              <a:rPr sz="1600" b="1" i="0">
+                <a:solidFill>
+                  <a:srgbClr val="5A6478"/>
+                </a:solidFill>
+                <a:latin typeface="Alegreya Sans"/>
+              </a:rPr>
+              <a:t>— Anna Wallace, Founder of WLA</a:t>
+            </a:r>
+          </a:p>
         </p:txBody>
       </p:sp>
       <p:sp>
         <p:nvSpPr>
           <p:cNvPr id="5" name="TextBox 4"/>
-          <p:cNvSpPr txBox="1"/>
-          <p:nvPr/>
-        </p:nvSpPr>
-        <p:spPr>
-          <a:xfrm>
-            <a:off x="1371600" y="5120640"/>
-            <a:ext cx="9418320" cy="457200"/>
-          </a:xfrm>
-          <a:prstGeom prst="rect">
-            <a:avLst/>
-          </a:prstGeom>
-          <a:noFill/>
-        </p:spPr>
-        <p:txBody>
-          <a:bodyPr wrap="square" lIns="0" rIns="0" tIns="0" bIns="0" anchor="t">
-            <a:spAutoFit/>
-          </a:bodyPr>
-          <a:lstStyle/>
-          <a:p>
-            <a:pPr algn="ctr">
-              <a:lnSpc>
-                <a:spcPct val="120000"/>
-              </a:lnSpc>
-            </a:pPr>
-            <a:r>
-              <a:rPr sz="1600" b="1" i="0" spc="200">
-                <a:solidFill>
-                  <a:srgbClr val="5A6478"/>
-                </a:solidFill>
-                <a:latin typeface="Alegreya Sans"/>
-              </a:rPr>
-              <a:t>— Anna Wallace, Founder of WLA</a:t>
-            </a:r>
-          </a:p>
-        </p:txBody>
-      </p:sp>
-      <p:sp>
-        <p:nvSpPr>
-          <p:cNvPr id="6" name="TextBox 5"/>
           <p:cNvSpPr txBox="1"/>
           <p:nvPr/>
         </p:nvSpPr>
@@ -3723,7 +3703,7 @@
       </p:sp>
       <p:sp>
         <p:nvSpPr>
-          <p:cNvPr id="7" name="TextBox 6"/>
+          <p:cNvPr id="6" name="TextBox 5"/>
           <p:cNvSpPr txBox="1"/>
           <p:nvPr/>
         </p:nvSpPr>
@@ -7805,8 +7785,8 @@
         </p:nvSpPr>
         <p:spPr>
           <a:xfrm>
-            <a:off x="4206240" y="1097280"/>
-            <a:ext cx="3749039" cy="365760"/>
+            <a:off x="4206240" y="1280160"/>
+            <a:ext cx="3749039" cy="457200"/>
           </a:xfrm>
           <a:prstGeom prst="roundRect">
             <a:avLst>
@@ -7861,7 +7841,7 @@
         <p:spPr>
           <a:xfrm>
             <a:off x="457200" y="2286000"/>
-            <a:ext cx="11338560" cy="3200400"/>
+            <a:ext cx="11338560" cy="4114800"/>
           </a:xfrm>
           <a:prstGeom prst="rect">
             <a:avLst/>
@@ -7880,7 +7860,7 @@
               </a:lnSpc>
             </a:pPr>
             <a:r>
-              <a:rPr sz="7000" b="1" i="0">
+              <a:rPr sz="6400" b="1" i="0">
                 <a:solidFill>
                   <a:srgbClr val="FFFFFF"/>
                 </a:solidFill>
@@ -7894,9 +7874,12 @@
               <a:lnSpc>
                 <a:spcPct val="105000"/>
               </a:lnSpc>
-            </a:pPr>
-            <a:r>
-              <a:rPr sz="9000" b="1" i="1">
+              <a:spcAft>
+                <a:spcPts val="2000"/>
+              </a:spcAft>
+            </a:pPr>
+            <a:r>
+              <a:rPr sz="8800" b="1" i="1">
                 <a:solidFill>
                   <a:srgbClr val="E5917A"/>
                 </a:solidFill>
@@ -7905,50 +7888,27 @@
               <a:t>WLA App</a:t>
             </a:r>
           </a:p>
+          <a:p>
+            <a:pPr algn="ctr">
+              <a:lnSpc>
+                <a:spcPct val="130000"/>
+              </a:lnSpc>
+            </a:pPr>
+            <a:r>
+              <a:rPr sz="2400" b="0" i="1">
+                <a:solidFill>
+                  <a:srgbClr val="F4EBDC"/>
+                </a:solidFill>
+                <a:latin typeface="Libre Baskerville"/>
+              </a:rPr>
+              <a:t>Support in your pocket. Every single day.</a:t>
+            </a:r>
+          </a:p>
         </p:txBody>
       </p:sp>
       <p:sp>
         <p:nvSpPr>
           <p:cNvPr id="5" name="TextBox 4"/>
-          <p:cNvSpPr txBox="1"/>
-          <p:nvPr/>
-        </p:nvSpPr>
-        <p:spPr>
-          <a:xfrm>
-            <a:off x="822960" y="5760720"/>
-            <a:ext cx="10515600" cy="457200"/>
-          </a:xfrm>
-          <a:prstGeom prst="rect">
-            <a:avLst/>
-          </a:prstGeom>
-          <a:noFill/>
-        </p:spPr>
-        <p:txBody>
-          <a:bodyPr wrap="square" lIns="0" rIns="0" tIns="0" bIns="0" anchor="t">
-            <a:spAutoFit/>
-          </a:bodyPr>
-          <a:lstStyle/>
-          <a:p>
-            <a:pPr algn="ctr">
-              <a:lnSpc>
-                <a:spcPct val="120000"/>
-              </a:lnSpc>
-            </a:pPr>
-            <a:r>
-              <a:rPr sz="2200" b="0" i="1">
-                <a:solidFill>
-                  <a:srgbClr val="F4EBDC"/>
-                </a:solidFill>
-                <a:latin typeface="Libre Baskerville"/>
-              </a:rPr>
-              <a:t>Support in your pocket. Every single day.</a:t>
-            </a:r>
-          </a:p>
-        </p:txBody>
-      </p:sp>
-      <p:sp>
-        <p:nvSpPr>
-          <p:cNvPr id="6" name="TextBox 5"/>
           <p:cNvSpPr txBox="1"/>
           <p:nvPr/>
         </p:nvSpPr>
@@ -7987,7 +7947,7 @@
       </p:sp>
       <p:sp>
         <p:nvSpPr>
-          <p:cNvPr id="7" name="TextBox 6"/>
+          <p:cNvPr id="6" name="TextBox 5"/>
           <p:cNvSpPr txBox="1"/>
           <p:nvPr/>
         </p:nvSpPr>
@@ -21418,8 +21378,8 @@
         </p:nvSpPr>
         <p:spPr>
           <a:xfrm>
-            <a:off x="3566160" y="914400"/>
-            <a:ext cx="5029200" cy="411480"/>
+            <a:off x="3383280" y="914400"/>
+            <a:ext cx="5394960" cy="502920"/>
           </a:xfrm>
           <a:prstGeom prst="roundRect">
             <a:avLst>
@@ -21454,7 +21414,7 @@
           <a:p>
             <a:pPr algn="ctr"/>
             <a:r>
-              <a:rPr sz="1600" b="1" spc="260">
+              <a:rPr sz="1600" b="1" spc="240">
                 <a:solidFill>
                   <a:srgbClr val="FFFFFF"/>
                 </a:solidFill>
@@ -21473,8 +21433,8 @@
         </p:nvSpPr>
         <p:spPr>
           <a:xfrm>
-            <a:off x="457200" y="2194560"/>
-            <a:ext cx="11338560" cy="3200400"/>
+            <a:off x="457200" y="2103120"/>
+            <a:ext cx="11338560" cy="4114800"/>
           </a:xfrm>
           <a:prstGeom prst="rect">
             <a:avLst/>
@@ -21516,6 +21476,9 @@
               <a:lnSpc>
                 <a:spcPct val="110000"/>
               </a:lnSpc>
+              <a:spcAft>
+                <a:spcPts val="2800"/>
+              </a:spcAft>
             </a:pPr>
             <a:r>
               <a:rPr sz="6000" b="1" i="0">
@@ -21527,50 +21490,27 @@
               <a:t>before public launch.</a:t>
             </a:r>
           </a:p>
+          <a:p>
+            <a:pPr algn="ctr">
+              <a:lnSpc>
+                <a:spcPct val="135000"/>
+              </a:lnSpc>
+            </a:pPr>
+            <a:r>
+              <a:rPr sz="2000" b="0" i="1">
+                <a:solidFill>
+                  <a:srgbClr val="0E2746"/>
+                </a:solidFill>
+                <a:latin typeface="Libre Baskerville"/>
+              </a:rPr>
+              <a:t>Because you’re already part of WLA, YOU get first access before anyone else.</a:t>
+            </a:r>
+          </a:p>
         </p:txBody>
       </p:sp>
       <p:sp>
         <p:nvSpPr>
           <p:cNvPr id="5" name="TextBox 4"/>
-          <p:cNvSpPr txBox="1"/>
-          <p:nvPr/>
-        </p:nvSpPr>
-        <p:spPr>
-          <a:xfrm>
-            <a:off x="822960" y="5486400"/>
-            <a:ext cx="10515600" cy="548640"/>
-          </a:xfrm>
-          <a:prstGeom prst="rect">
-            <a:avLst/>
-          </a:prstGeom>
-          <a:noFill/>
-        </p:spPr>
-        <p:txBody>
-          <a:bodyPr wrap="square" lIns="0" rIns="0" tIns="0" bIns="0" anchor="t">
-            <a:spAutoFit/>
-          </a:bodyPr>
-          <a:lstStyle/>
-          <a:p>
-            <a:pPr algn="ctr">
-              <a:lnSpc>
-                <a:spcPct val="120000"/>
-              </a:lnSpc>
-            </a:pPr>
-            <a:r>
-              <a:rPr sz="1900" b="0" i="1">
-                <a:solidFill>
-                  <a:srgbClr val="0E2746"/>
-                </a:solidFill>
-                <a:latin typeface="Libre Baskerville"/>
-              </a:rPr>
-              <a:t>Because you’re already part of WLA, YOU get first access before anyone else.</a:t>
-            </a:r>
-          </a:p>
-        </p:txBody>
-      </p:sp>
-      <p:sp>
-        <p:nvSpPr>
-          <p:cNvPr id="6" name="TextBox 5"/>
           <p:cNvSpPr txBox="1"/>
           <p:nvPr/>
         </p:nvSpPr>
@@ -21609,7 +21549,7 @@
       </p:sp>
       <p:sp>
         <p:nvSpPr>
-          <p:cNvPr id="7" name="TextBox 6"/>
+          <p:cNvPr id="6" name="TextBox 5"/>
           <p:cNvSpPr txBox="1"/>
           <p:nvPr/>
         </p:nvSpPr>
@@ -24155,8 +24095,8 @@
         </p:nvSpPr>
         <p:spPr>
           <a:xfrm>
-            <a:off x="822960" y="1097280"/>
-            <a:ext cx="10515600" cy="365760"/>
+            <a:off x="822960" y="777240"/>
+            <a:ext cx="10515600" cy="457200"/>
           </a:xfrm>
           <a:prstGeom prst="rect">
             <a:avLst/>
@@ -24194,8 +24134,8 @@
         </p:nvSpPr>
         <p:spPr>
           <a:xfrm>
-            <a:off x="822960" y="1920240"/>
-            <a:ext cx="10515600" cy="3200400"/>
+            <a:off x="822960" y="1737360"/>
+            <a:ext cx="10515600" cy="4572000"/>
           </a:xfrm>
           <a:prstGeom prst="rect">
             <a:avLst/>
@@ -24210,8 +24150,11 @@
           <a:p>
             <a:pPr algn="ctr">
               <a:lnSpc>
-                <a:spcPct val="120000"/>
-              </a:lnSpc>
+                <a:spcPct val="118000"/>
+              </a:lnSpc>
+              <a:spcAft>
+                <a:spcPts val="2800"/>
+              </a:spcAft>
             </a:pPr>
             <a:r>
               <a:rPr sz="4400" b="1" i="0">
@@ -24232,89 +24175,46 @@
               <a:t>another diet.</a:t>
             </a:r>
           </a:p>
+          <a:p>
+            <a:pPr algn="ctr">
+              <a:lnSpc>
+                <a:spcPct val="140000"/>
+              </a:lnSpc>
+              <a:spcAft>
+                <a:spcPts val="2000"/>
+              </a:spcAft>
+            </a:pPr>
+            <a:r>
+              <a:rPr sz="1900" b="0" i="0">
+                <a:solidFill>
+                  <a:srgbClr val="333333"/>
+                </a:solidFill>
+                <a:latin typeface="Alegreya Sans"/>
+              </a:rPr>
+              <a:t>It’s about continuing the habits, support and momentum you’ve already worked so hard to build.</a:t>
+            </a:r>
+          </a:p>
+          <a:p>
+            <a:pPr algn="ctr">
+              <a:lnSpc>
+                <a:spcPct val="140000"/>
+              </a:lnSpc>
+            </a:pPr>
+            <a:r>
+              <a:rPr sz="2000" b="0" i="1">
+                <a:solidFill>
+                  <a:srgbClr val="0E2746"/>
+                </a:solidFill>
+                <a:latin typeface="Libre Baskerville"/>
+              </a:rPr>
+              <a:t>The women who maintain their results long term are usually the women who continue living the WLA lifestyle.</a:t>
+            </a:r>
+          </a:p>
         </p:txBody>
       </p:sp>
       <p:sp>
         <p:nvSpPr>
           <p:cNvPr id="5" name="TextBox 4"/>
-          <p:cNvSpPr txBox="1"/>
-          <p:nvPr/>
-        </p:nvSpPr>
-        <p:spPr>
-          <a:xfrm>
-            <a:off x="822960" y="4023360"/>
-            <a:ext cx="10515600" cy="548640"/>
-          </a:xfrm>
-          <a:prstGeom prst="rect">
-            <a:avLst/>
-          </a:prstGeom>
-          <a:noFill/>
-        </p:spPr>
-        <p:txBody>
-          <a:bodyPr wrap="square" lIns="0" rIns="0" tIns="0" bIns="0" anchor="t">
-            <a:spAutoFit/>
-          </a:bodyPr>
-          <a:lstStyle/>
-          <a:p>
-            <a:pPr algn="ctr">
-              <a:lnSpc>
-                <a:spcPct val="120000"/>
-              </a:lnSpc>
-            </a:pPr>
-            <a:r>
-              <a:rPr sz="1800" b="0" i="0">
-                <a:solidFill>
-                  <a:srgbClr val="333333"/>
-                </a:solidFill>
-                <a:latin typeface="Alegreya Sans"/>
-              </a:rPr>
-              <a:t>It’s about continuing the habits, support and momentum you’ve already worked so hard to build.</a:t>
-            </a:r>
-          </a:p>
-        </p:txBody>
-      </p:sp>
-      <p:sp>
-        <p:nvSpPr>
-          <p:cNvPr id="6" name="TextBox 5"/>
-          <p:cNvSpPr txBox="1"/>
-          <p:nvPr/>
-        </p:nvSpPr>
-        <p:spPr>
-          <a:xfrm>
-            <a:off x="822960" y="4937760"/>
-            <a:ext cx="10515600" cy="548640"/>
-          </a:xfrm>
-          <a:prstGeom prst="rect">
-            <a:avLst/>
-          </a:prstGeom>
-          <a:noFill/>
-        </p:spPr>
-        <p:txBody>
-          <a:bodyPr wrap="square" lIns="0" rIns="0" tIns="0" bIns="0" anchor="t">
-            <a:spAutoFit/>
-          </a:bodyPr>
-          <a:lstStyle/>
-          <a:p>
-            <a:pPr algn="ctr">
-              <a:lnSpc>
-                <a:spcPct val="120000"/>
-              </a:lnSpc>
-            </a:pPr>
-            <a:r>
-              <a:rPr sz="1900" b="0" i="1">
-                <a:solidFill>
-                  <a:srgbClr val="0E2746"/>
-                </a:solidFill>
-                <a:latin typeface="Libre Baskerville"/>
-              </a:rPr>
-              <a:t>The women who maintain their results long term are usually the women who continue living the WLA lifestyle.</a:t>
-            </a:r>
-          </a:p>
-        </p:txBody>
-      </p:sp>
-      <p:sp>
-        <p:nvSpPr>
-          <p:cNvPr id="7" name="TextBox 6"/>
           <p:cNvSpPr txBox="1"/>
           <p:nvPr/>
         </p:nvSpPr>
@@ -24353,7 +24253,7 @@
       </p:sp>
       <p:sp>
         <p:nvSpPr>
-          <p:cNvPr id="8" name="TextBox 7"/>
+          <p:cNvPr id="6" name="TextBox 5"/>
           <p:cNvSpPr txBox="1"/>
           <p:nvPr/>
         </p:nvSpPr>
@@ -25749,8 +25649,8 @@
         </p:nvSpPr>
         <p:spPr>
           <a:xfrm>
-            <a:off x="3383280" y="914400"/>
-            <a:ext cx="5394960" cy="411480"/>
+            <a:off x="3200400" y="914400"/>
+            <a:ext cx="5760720" cy="502920"/>
           </a:xfrm>
           <a:prstGeom prst="roundRect">
             <a:avLst>
@@ -25804,8 +25704,8 @@
         </p:nvSpPr>
         <p:spPr>
           <a:xfrm>
-            <a:off x="457200" y="2103120"/>
-            <a:ext cx="11338560" cy="3200400"/>
+            <a:off x="457200" y="2011680"/>
+            <a:ext cx="11338560" cy="4572000"/>
           </a:xfrm>
           <a:prstGeom prst="rect">
             <a:avLst/>
@@ -25822,6 +25722,9 @@
               <a:lnSpc>
                 <a:spcPct val="115000"/>
               </a:lnSpc>
+              <a:spcAft>
+                <a:spcPts val="2800"/>
+              </a:spcAft>
             </a:pPr>
             <a:r>
               <a:rPr sz="5000" b="1" i="0">
@@ -25851,89 +25754,46 @@
               <a:t>.</a:t>
             </a:r>
           </a:p>
+          <a:p>
+            <a:pPr algn="ctr">
+              <a:lnSpc>
+                <a:spcPct val="135000"/>
+              </a:lnSpc>
+              <a:spcAft>
+                <a:spcPts val="2000"/>
+              </a:spcAft>
+            </a:pPr>
+            <a:r>
+              <a:rPr sz="2200" b="0" i="1">
+                <a:solidFill>
+                  <a:srgbClr val="0E2746"/>
+                </a:solidFill>
+                <a:latin typeface="Libre Baskerville"/>
+              </a:rPr>
+              <a:t>Not just losing weight. Building a lifestyle that helps you KEEP the results too.</a:t>
+            </a:r>
+          </a:p>
+          <a:p>
+            <a:pPr algn="ctr">
+              <a:lnSpc>
+                <a:spcPct val="140000"/>
+              </a:lnSpc>
+            </a:pPr>
+            <a:r>
+              <a:rPr sz="1800" b="0" i="0">
+                <a:solidFill>
+                  <a:srgbClr val="333333"/>
+                </a:solidFill>
+                <a:latin typeface="Alegreya Sans"/>
+              </a:rPr>
+              <a:t>I truly believe this next phase of WLA is going to change everything for so many women.</a:t>
+            </a:r>
+          </a:p>
         </p:txBody>
       </p:sp>
       <p:sp>
         <p:nvSpPr>
           <p:cNvPr id="5" name="TextBox 4"/>
-          <p:cNvSpPr txBox="1"/>
-          <p:nvPr/>
-        </p:nvSpPr>
-        <p:spPr>
-          <a:xfrm>
-            <a:off x="822960" y="4206240"/>
-            <a:ext cx="10515600" cy="548640"/>
-          </a:xfrm>
-          <a:prstGeom prst="rect">
-            <a:avLst/>
-          </a:prstGeom>
-          <a:noFill/>
-        </p:spPr>
-        <p:txBody>
-          <a:bodyPr wrap="square" lIns="0" rIns="0" tIns="0" bIns="0" anchor="t">
-            <a:spAutoFit/>
-          </a:bodyPr>
-          <a:lstStyle/>
-          <a:p>
-            <a:pPr algn="ctr">
-              <a:lnSpc>
-                <a:spcPct val="120000"/>
-              </a:lnSpc>
-            </a:pPr>
-            <a:r>
-              <a:rPr sz="2100" b="0" i="1">
-                <a:solidFill>
-                  <a:srgbClr val="0E2746"/>
-                </a:solidFill>
-                <a:latin typeface="Libre Baskerville"/>
-              </a:rPr>
-              <a:t>Not just losing weight. Building a lifestyle that helps you KEEP the results too.</a:t>
-            </a:r>
-          </a:p>
-        </p:txBody>
-      </p:sp>
-      <p:sp>
-        <p:nvSpPr>
-          <p:cNvPr id="6" name="TextBox 5"/>
-          <p:cNvSpPr txBox="1"/>
-          <p:nvPr/>
-        </p:nvSpPr>
-        <p:spPr>
-          <a:xfrm>
-            <a:off x="822960" y="5212080"/>
-            <a:ext cx="10515600" cy="457200"/>
-          </a:xfrm>
-          <a:prstGeom prst="rect">
-            <a:avLst/>
-          </a:prstGeom>
-          <a:noFill/>
-        </p:spPr>
-        <p:txBody>
-          <a:bodyPr wrap="square" lIns="0" rIns="0" tIns="0" bIns="0" anchor="t">
-            <a:spAutoFit/>
-          </a:bodyPr>
-          <a:lstStyle/>
-          <a:p>
-            <a:pPr algn="ctr">
-              <a:lnSpc>
-                <a:spcPct val="120000"/>
-              </a:lnSpc>
-            </a:pPr>
-            <a:r>
-              <a:rPr sz="1700" b="0" i="0">
-                <a:solidFill>
-                  <a:srgbClr val="333333"/>
-                </a:solidFill>
-                <a:latin typeface="Alegreya Sans"/>
-              </a:rPr>
-              <a:t>I truly believe this next phase of WLA is going to change everything for so many women.</a:t>
-            </a:r>
-          </a:p>
-        </p:txBody>
-      </p:sp>
-      <p:sp>
-        <p:nvSpPr>
-          <p:cNvPr id="7" name="TextBox 6"/>
           <p:cNvSpPr txBox="1"/>
           <p:nvPr/>
         </p:nvSpPr>
@@ -25972,7 +25832,7 @@
       </p:sp>
       <p:sp>
         <p:nvSpPr>
-          <p:cNvPr id="8" name="TextBox 7"/>
+          <p:cNvPr id="6" name="TextBox 5"/>
           <p:cNvSpPr txBox="1"/>
           <p:nvPr/>
         </p:nvSpPr>
@@ -26079,8 +25939,8 @@
         </p:nvSpPr>
         <p:spPr>
           <a:xfrm>
-            <a:off x="4754880" y="1280160"/>
-            <a:ext cx="2651760" cy="365760"/>
+            <a:off x="4754880" y="1554480"/>
+            <a:ext cx="2651760" cy="457200"/>
           </a:xfrm>
           <a:prstGeom prst="roundRect">
             <a:avLst>
@@ -26134,8 +25994,8 @@
         </p:nvSpPr>
         <p:spPr>
           <a:xfrm>
-            <a:off x="1097280" y="2194560"/>
-            <a:ext cx="9966960" cy="3200400"/>
+            <a:off x="1097280" y="2651760"/>
+            <a:ext cx="9966960" cy="3657600"/>
           </a:xfrm>
           <a:prstGeom prst="rect">
             <a:avLst/>
@@ -26152,6 +26012,9 @@
               <a:lnSpc>
                 <a:spcPct val="115000"/>
               </a:lnSpc>
+              <a:spcAft>
+                <a:spcPts val="2400"/>
+              </a:spcAft>
             </a:pPr>
             <a:r>
               <a:rPr sz="6400" b="0" i="1">
@@ -26181,50 +26044,27 @@
               <a:t>.”</a:t>
             </a:r>
           </a:p>
+          <a:p>
+            <a:pPr algn="ctr">
+              <a:lnSpc>
+                <a:spcPct val="135000"/>
+              </a:lnSpc>
+            </a:pPr>
+            <a:r>
+              <a:rPr sz="2000" b="0" i="0">
+                <a:solidFill>
+                  <a:srgbClr val="F4EBDC"/>
+                </a:solidFill>
+                <a:latin typeface="Alegreya Sans"/>
+              </a:rPr>
+              <a:t>And THAT is the cycle we want to help women finally break for good.</a:t>
+            </a:r>
+          </a:p>
         </p:txBody>
       </p:sp>
       <p:sp>
         <p:nvSpPr>
           <p:cNvPr id="5" name="TextBox 4"/>
-          <p:cNvSpPr txBox="1"/>
-          <p:nvPr/>
-        </p:nvSpPr>
-        <p:spPr>
-          <a:xfrm>
-            <a:off x="1371600" y="4846320"/>
-            <a:ext cx="9418320" cy="548640"/>
-          </a:xfrm>
-          <a:prstGeom prst="rect">
-            <a:avLst/>
-          </a:prstGeom>
-          <a:noFill/>
-        </p:spPr>
-        <p:txBody>
-          <a:bodyPr wrap="square" lIns="0" rIns="0" tIns="0" bIns="0" anchor="t">
-            <a:spAutoFit/>
-          </a:bodyPr>
-          <a:lstStyle/>
-          <a:p>
-            <a:pPr algn="ctr">
-              <a:lnSpc>
-                <a:spcPct val="120000"/>
-              </a:lnSpc>
-            </a:pPr>
-            <a:r>
-              <a:rPr sz="1800" b="0" i="0">
-                <a:solidFill>
-                  <a:srgbClr val="F4EBDC"/>
-                </a:solidFill>
-                <a:latin typeface="Alegreya Sans"/>
-              </a:rPr>
-              <a:t>And THAT is the cycle we want to help women finally break for good.</a:t>
-            </a:r>
-          </a:p>
-        </p:txBody>
-      </p:sp>
-      <p:sp>
-        <p:nvSpPr>
-          <p:cNvPr id="6" name="TextBox 5"/>
           <p:cNvSpPr txBox="1"/>
           <p:nvPr/>
         </p:nvSpPr>
@@ -26263,7 +26103,7 @@
       </p:sp>
       <p:sp>
         <p:nvSpPr>
-          <p:cNvPr id="7" name="TextBox 6"/>
+          <p:cNvPr id="6" name="TextBox 5"/>
           <p:cNvSpPr txBox="1"/>
           <p:nvPr/>
         </p:nvSpPr>
@@ -26370,8 +26210,8 @@
         </p:nvSpPr>
         <p:spPr>
           <a:xfrm>
-            <a:off x="4114800" y="1097280"/>
-            <a:ext cx="3931920" cy="411480"/>
+            <a:off x="3931920" y="868680"/>
+            <a:ext cx="4297680" cy="502920"/>
           </a:xfrm>
           <a:prstGeom prst="roundRect">
             <a:avLst>
@@ -26406,7 +26246,7 @@
           <a:p>
             <a:pPr algn="ctr"/>
             <a:r>
-              <a:rPr sz="1500" b="1" spc="260">
+              <a:rPr sz="1500" b="1" spc="240">
                 <a:solidFill>
                   <a:srgbClr val="FFFFFF"/>
                 </a:solidFill>
@@ -26425,8 +26265,8 @@
         </p:nvSpPr>
         <p:spPr>
           <a:xfrm>
-            <a:off x="457200" y="2286000"/>
-            <a:ext cx="11338560" cy="3200400"/>
+            <a:off x="457200" y="1828800"/>
+            <a:ext cx="11338560" cy="2743200"/>
           </a:xfrm>
           <a:prstGeom prst="rect">
             <a:avLst/>
@@ -26489,8 +26329,8 @@
         </p:nvSpPr>
         <p:spPr>
           <a:xfrm>
-            <a:off x="4023360" y="5120640"/>
-            <a:ext cx="4114800" cy="685800"/>
+            <a:off x="3840480" y="4663440"/>
+            <a:ext cx="4480560" cy="777240"/>
           </a:xfrm>
           <a:prstGeom prst="roundRect">
             <a:avLst>
@@ -26535,8 +26375,8 @@
         </p:nvSpPr>
         <p:spPr>
           <a:xfrm>
-            <a:off x="4023360" y="5120640"/>
-            <a:ext cx="4114800" cy="685800"/>
+            <a:off x="3840480" y="4663440"/>
+            <a:ext cx="4480560" cy="777240"/>
           </a:xfrm>
           <a:prstGeom prst="rect">
             <a:avLst/>
@@ -26574,7 +26414,7 @@
         </p:nvSpPr>
         <p:spPr>
           <a:xfrm>
-            <a:off x="457200" y="6035040"/>
+            <a:off x="457200" y="5623560"/>
             <a:ext cx="11338560" cy="365760"/>
           </a:xfrm>
           <a:prstGeom prst="rect">

</xml_diff>